<commit_message>
neuneu code und so
</commit_message>
<xml_diff>
--- a/Dokumentation/Thermische Analyse/Bilder Waerme/Wärmevergleich_Messung.pptx
+++ b/Dokumentation/Thermische Analyse/Bilder Waerme/Wärmevergleich_Messung.pptx
@@ -3502,9 +3502,10 @@
           <a:p>
             <a:pPr algn="ctr"/>
             <a:r>
-              <a:rPr lang="de-DE" dirty="0"/>
-              <a:t>Regelstrom [A]</a:t>
-            </a:r>
+              <a:rPr lang="de-DE"/>
+              <a:t>Regelstrom</a:t>
+            </a:r>
+            <a:endParaRPr lang="de-DE" dirty="0"/>
           </a:p>
           <a:p>
             <a:pPr algn="ctr"/>

</xml_diff>